<commit_message>
clean up local paths in screenshots
</commit_message>
<xml_diff>
--- a/demo/ClinicFlow-DevOps-Capstone.pptx
+++ b/demo/ClinicFlow-DevOps-Capstone.pptx
@@ -121,13 +121,13 @@
   <p:extLst>
     <p:ext uri="{521415D9-36F7-43E2-AB2F-B90AF26B5E84}">
       <p14:sectionLst xmlns:p14="http://schemas.microsoft.com/office/powerpoint/2010/main">
-        <p14:section name="Intro" id="{8ad46294-da68-8d44-4d09-e362ad9a465d}">
+        <p14:section name="Intro" id="{1dd9f172-1521-6581-b711-82a50f029775}">
           <p14:sldIdLst>
             <p14:sldId id="256"/>
             <p14:sldId id="257"/>
           </p14:sldIdLst>
         </p14:section>
-        <p14:section name="Pipeline" id="{4bcb9125-7915-3c47-8b45-60e3831a476f}">
+        <p14:section name="Pipeline" id="{d8f5cb88-cc7b-dd31-60c8-c11ceece4c3e}">
           <p14:sldIdLst>
             <p14:sldId id="258"/>
             <p14:sldId id="259"/>
@@ -136,28 +136,28 @@
             <p14:sldId id="262"/>
           </p14:sldIdLst>
         </p14:section>
-        <p14:section name="Security" id="{2bd63ab5-2ec1-eda4-46f6-e31c1ba2d49b}">
+        <p14:section name="Security" id="{54d47c57-40de-35a5-f9bb-209cc1b663b3}">
           <p14:sldIdLst>
             <p14:sldId id="263"/>
           </p14:sldIdLst>
         </p14:section>
-        <p14:section name="Infrastructure" id="{6f03e8ce-dbc6-aa35-44ab-0bf468048ac4}">
+        <p14:section name="Infrastructure" id="{b0d8d27d-e2e4-3dfb-810f-80319d6fcf7e}">
           <p14:sldIdLst>
             <p14:sldId id="264"/>
           </p14:sldIdLst>
         </p14:section>
-        <p14:section name="Kubernetes" id="{250110dc-dbe9-2095-d218-50793401916b}">
+        <p14:section name="Kubernetes" id="{96456c8d-2831-8fbb-62ce-0c3928e3821f}">
           <p14:sldIdLst>
             <p14:sldId id="265"/>
             <p14:sldId id="266"/>
           </p14:sldIdLst>
         </p14:section>
-        <p14:section name="Monitoring" id="{f721873a-a087-cd17-c96c-0e28a94f3404}">
+        <p14:section name="Monitoring" id="{5c40ee85-6ca4-d5b8-b932-8c1e251158b2}">
           <p14:sldIdLst>
             <p14:sldId id="267"/>
           </p14:sldIdLst>
         </p14:section>
-        <p14:section name="Demo" id="{85f2d7e2-2410-3c83-ff74-caff0f2c061a}">
+        <p14:section name="Demo" id="{377f9434-60f9-ee11-aabe-b864f6c23ef1}">
           <p14:sldIdLst>
             <p14:sldId id="268"/>
             <p14:sldId id="269"/>

</xml_diff>